<commit_message>
docs: update presentation and README slides with detailed feature, architecture, and query flow documentation
</commit_message>
<xml_diff>
--- a/docs/project_flow_presentation.pptx
+++ b/docs/project_flow_presentation.pptx
@@ -10,6 +10,8 @@
     <p:sldId id="258" r:id="rId9"/>
     <p:sldId id="259" r:id="rId10"/>
     <p:sldId id="260" r:id="rId11"/>
+    <p:sldId id="261" r:id="rId12"/>
+    <p:sldId id="262" r:id="rId13"/>
   </p:sldIdLst>
   <p:sldSz cx="9144000" cy="6858000" type="screen4x3"/>
   <p:notesSz cx="6858000" cy="9144000"/>
@@ -3108,8 +3110,8 @@
         </p:nvSpPr>
         <p:spPr>
           <a:xfrm>
-            <a:off x="685800" y="2011680"/>
-            <a:ext cx="7772400" cy="2743200"/>
+            <a:off x="685800" y="1645920"/>
+            <a:ext cx="7772400" cy="3657600"/>
           </a:xfrm>
           <a:prstGeom prst="rect">
             <a:avLst/>
@@ -3122,40 +3124,45 @@
           </a:bodyPr>
           <a:lstStyle/>
           <a:p>
-            <a:pPr algn="l">
-              <a:defRPr b="1" sz="4000">
+            <a:pPr>
+              <a:spcAft>
+                <a:spcPts val="800"/>
+              </a:spcAft>
+              <a:defRPr b="1" sz="3800">
                 <a:solidFill>
                   <a:srgbClr val="38BDF8"/>
                 </a:solidFill>
               </a:defRPr>
             </a:pPr>
             <a:r>
-              <a:t>AI-Powered Telegram Message Search</a:t>
-            </a:r>
-          </a:p>
-          <a:p>
-            <a:pPr algn="l">
-              <a:defRPr sz="2000">
+              <a:t>AI Telegram Message Search Engine</a:t>
+            </a:r>
+          </a:p>
+          <a:p>
+            <a:pPr>
+              <a:spcAft>
+                <a:spcPts val="2000"/>
+              </a:spcAft>
+              <a:defRPr sz="1800" b="1">
                 <a:solidFill>
                   <a:srgbClr val="F1F5F9"/>
                 </a:solidFill>
               </a:defRPr>
             </a:pPr>
             <a:r>
-              <a:t>System Architecture &amp; Flow Walkthrough for Recruiters</a:t>
-            </a:r>
-          </a:p>
-          <a:p>
-            <a:br/>
-            <a:pPr algn="l">
-              <a:defRPr sz="1400" i="1">
+              <a:t>Deep Dive: System Architecture, Database Flows &amp; Search Pipeline</a:t>
+            </a:r>
+          </a:p>
+          <a:p>
+            <a:pPr>
+              <a:defRPr sz="1400">
                 <a:solidFill>
                   <a:srgbClr val="94A3B8"/>
                 </a:solidFill>
               </a:defRPr>
             </a:pPr>
             <a:r>
-              <a:t>Production-Grade Semantic Vector Search Platform</a:t>
+              <a:t>An enterprise-grade monorepo full-stack application leveraging decoupled PostgreSQL and Qdrant Cloud Vector Database.</a:t>
             </a:r>
           </a:p>
         </p:txBody>
@@ -3194,8 +3201,8 @@
         </p:nvSpPr>
         <p:spPr>
           <a:xfrm>
-            <a:off x="685800" y="457200"/>
-            <a:ext cx="7772400" cy="914400"/>
+            <a:off x="685800" y="365760"/>
+            <a:ext cx="7772400" cy="1005840"/>
           </a:xfrm>
           <a:prstGeom prst="rect">
             <a:avLst/>
@@ -3209,14 +3216,26 @@
           <a:lstStyle/>
           <a:p>
             <a:pPr>
-              <a:defRPr b="1" sz="2800">
+              <a:defRPr b="1" sz="2600">
                 <a:solidFill>
                   <a:srgbClr val="38BDF8"/>
                 </a:solidFill>
               </a:defRPr>
             </a:pPr>
             <a:r>
-              <a:t>1. The Problem &amp; The Solution</a:t>
+              <a:t>1. Rich Application Features</a:t>
+            </a:r>
+          </a:p>
+          <a:p>
+            <a:pPr>
+              <a:defRPr sz="1400" i="1">
+                <a:solidFill>
+                  <a:srgbClr val="94A3B8"/>
+                </a:solidFill>
+              </a:defRPr>
+            </a:pPr>
+            <a:r>
+              <a:t>Key interface modules and functionalities available to the user</a:t>
             </a:r>
           </a:p>
         </p:txBody>
@@ -3230,7 +3249,7 @@
         <p:spPr>
           <a:xfrm>
             <a:off x="685800" y="1371600"/>
-            <a:ext cx="7772400" cy="4572000"/>
+            <a:ext cx="7772400" cy="4754880"/>
           </a:xfrm>
           <a:prstGeom prst="rect">
             <a:avLst/>
@@ -3245,93 +3264,139 @@
           <a:p>
             <a:pPr>
               <a:spcAft>
-                <a:spcPts val="1400"/>
+                <a:spcPts val="1000"/>
               </a:spcAft>
             </a:pPr>
             <a:r>
-              <a:rPr b="1" sz="1800">
+              <a:rPr b="1" sz="1600">
                 <a:solidFill>
                   <a:srgbClr val="F1F5F9"/>
                 </a:solidFill>
               </a:rPr>
-              <a:t>The Challenge:</a:t>
-            </a:r>
-            <a:r>
-              <a:rPr b="0" sz="1600">
+              <a:t>🤖 Semantic AI Querying:</a:t>
+            </a:r>
+            <a:r>
+              <a:rPr sz="1500">
                 <a:solidFill>
                   <a:srgbClr val="CBD5E1"/>
                 </a:solidFill>
               </a:rPr>
-              <a:t> Telegram export files contain tens of thousands of unstructured conversational chat logs.</a:t>
+              <a:t> Maps natural language queries to coordinates (e.g. searching 'threats' surfaces Zero-day exploits).</a:t>
             </a:r>
           </a:p>
           <a:p>
             <a:pPr>
               <a:spcAft>
-                <a:spcPts val="1400"/>
+                <a:spcPts val="1000"/>
               </a:spcAft>
             </a:pPr>
             <a:r>
-              <a:rPr b="1" sz="1800">
+              <a:rPr b="1" sz="1600">
                 <a:solidFill>
                   <a:srgbClr val="F1F5F9"/>
                 </a:solidFill>
               </a:rPr>
-              <a:t>Limitations of Keyword Search:</a:t>
-            </a:r>
-            <a:r>
-              <a:rPr b="0" sz="1600">
+              <a:t>⚡ Preset Intel Chips:</a:t>
+            </a:r>
+            <a:r>
+              <a:rPr sz="1500">
                 <a:solidFill>
                   <a:srgbClr val="CBD5E1"/>
                 </a:solidFill>
               </a:rPr>
-              <a:t> Traditional exact-match text searches (e.g. Ctrl+F) fail to catch synonyms, context, or variations (e.g., searching for 'drugs' won't surface 'cocaine' or 'MDMA').</a:t>
+              <a:t> Single-click presets search threat categories (Malware, Drugs, Fraud, Suspicious messages).</a:t>
             </a:r>
           </a:p>
           <a:p>
             <a:pPr>
               <a:spcAft>
-                <a:spcPts val="1400"/>
+                <a:spcPts val="1000"/>
               </a:spcAft>
             </a:pPr>
             <a:r>
-              <a:rPr b="1" sz="1800">
+              <a:rPr b="1" sz="1600">
                 <a:solidFill>
                   <a:srgbClr val="F1F5F9"/>
                 </a:solidFill>
               </a:rPr>
-              <a:t>The AI Solution:</a:t>
-            </a:r>
-            <a:r>
-              <a:rPr b="0" sz="1600">
+              <a:t>📁 File Scope Switcher:</a:t>
+            </a:r>
+            <a:r>
+              <a:rPr sz="1500">
                 <a:solidFill>
                   <a:srgbClr val="CBD5E1"/>
                 </a:solidFill>
               </a:rPr>
-              <a:t> Converts raw messages into high-dimensional vector embeddings, mapping text based on semantic meaning rather than character strings.</a:t>
+              <a:t> Instantly toggle search focus between 'Current Upload Only' and 'All Historical Exports'.</a:t>
             </a:r>
           </a:p>
           <a:p>
             <a:pPr>
               <a:spcAft>
-                <a:spcPts val="1400"/>
+                <a:spcPts val="1000"/>
               </a:spcAft>
             </a:pPr>
             <a:r>
-              <a:rPr b="1" sz="1800">
+              <a:rPr b="1" sz="1600">
                 <a:solidFill>
                   <a:srgbClr val="F1F5F9"/>
                 </a:solidFill>
               </a:rPr>
-              <a:t>Business Applications:</a:t>
-            </a:r>
-            <a:r>
-              <a:rPr b="0" sz="1600">
+              <a:t>🎛️ Dynamic Relevance Slider:</a:t>
+            </a:r>
+            <a:r>
+              <a:rPr sz="1500">
                 <a:solidFill>
                   <a:srgbClr val="CBD5E1"/>
                 </a:solidFill>
               </a:rPr>
-              <a:t> Instant compliance scanning, threat intelligence auditing, and threat detection inside enterprise communications.</a:t>
+              <a:t> Adjustable threshold filter (0% - 95%) that isolates semantic matches from noise.</a:t>
+            </a:r>
+          </a:p>
+          <a:p>
+            <a:pPr>
+              <a:spcAft>
+                <a:spcPts val="1000"/>
+              </a:spcAft>
+            </a:pPr>
+            <a:r>
+              <a:rPr b="1" sz="1600">
+                <a:solidFill>
+                  <a:srgbClr val="F1F5F9"/>
+                </a:solidFill>
+              </a:rPr>
+              <a:t>📊 Rich Result Cards:</a:t>
+            </a:r>
+            <a:r>
+              <a:rPr sz="1500">
+                <a:solidFill>
+                  <a:srgbClr val="CBD5E1"/>
+                </a:solidFill>
+              </a:rPr>
+              <a:t> Displays timestamp, sender handles, context threads (replies), and precise AI match percentages.</a:t>
+            </a:r>
+          </a:p>
+          <a:p>
+            <a:pPr>
+              <a:spcAft>
+                <a:spcPts val="1000"/>
+              </a:spcAft>
+            </a:pPr>
+            <a:r>
+              <a:rPr b="1" sz="1600">
+                <a:solidFill>
+                  <a:srgbClr val="F1F5F9"/>
+                </a:solidFill>
+              </a:rPr>
+              <a:t>⏱️ Performance Indicator:</a:t>
+            </a:r>
+            <a:r>
+              <a:rPr sz="1500">
+                <a:solidFill>
+                  <a:srgbClr val="CBD5E1"/>
+                </a:solidFill>
+              </a:rPr>
+              <a:t> Real-time query execution latency counter (always sub-10ms) showing database efficiency.</a:t>
             </a:r>
           </a:p>
         </p:txBody>
@@ -3370,8 +3435,8 @@
         </p:nvSpPr>
         <p:spPr>
           <a:xfrm>
-            <a:off x="685800" y="457200"/>
-            <a:ext cx="7772400" cy="914400"/>
+            <a:off x="685800" y="365760"/>
+            <a:ext cx="7772400" cy="1005840"/>
           </a:xfrm>
           <a:prstGeom prst="rect">
             <a:avLst/>
@@ -3385,14 +3450,26 @@
           <a:lstStyle/>
           <a:p>
             <a:pPr>
-              <a:defRPr b="1" sz="2800">
+              <a:defRPr b="1" sz="2600">
                 <a:solidFill>
                   <a:srgbClr val="38BDF8"/>
                 </a:solidFill>
               </a:defRPr>
             </a:pPr>
             <a:r>
-              <a:t>2. High-Level System Architecture</a:t>
+              <a:t>2. Decoupled System Architecture</a:t>
+            </a:r>
+          </a:p>
+          <a:p>
+            <a:pPr>
+              <a:defRPr sz="1400" i="1">
+                <a:solidFill>
+                  <a:srgbClr val="94A3B8"/>
+                </a:solidFill>
+              </a:defRPr>
+            </a:pPr>
+            <a:r>
+              <a:t>A multi-tier production-grade design ensuring high reliability and separation of concerns</a:t>
             </a:r>
           </a:p>
         </p:txBody>
@@ -3406,7 +3483,7 @@
         <p:spPr>
           <a:xfrm>
             <a:off x="685800" y="1371600"/>
-            <a:ext cx="7772400" cy="4572000"/>
+            <a:ext cx="7772400" cy="4754880"/>
           </a:xfrm>
           <a:prstGeom prst="rect">
             <a:avLst/>
@@ -3421,93 +3498,116 @@
           <a:p>
             <a:pPr>
               <a:spcAft>
-                <a:spcPts val="1400"/>
+                <a:spcPts val="1000"/>
               </a:spcAft>
             </a:pPr>
             <a:r>
-              <a:rPr b="1" sz="1800">
+              <a:rPr b="1" sz="1600">
                 <a:solidFill>
                   <a:srgbClr val="F1F5F9"/>
                 </a:solidFill>
               </a:rPr>
-              <a:t>Client Tier:</a:t>
-            </a:r>
-            <a:r>
-              <a:rPr b="0" sz="1600">
+              <a:t>Frontend (Client Tier):</a:t>
+            </a:r>
+            <a:r>
+              <a:rPr sz="1500">
                 <a:solidFill>
                   <a:srgbClr val="CBD5E1"/>
                 </a:solidFill>
               </a:rPr>
-              <a:t> Responsive Next.js 14/15 Frontend (React UI &amp; Tailwind CSS) offering drag-and-drop file ingestion, dynamic search sliders, and real-time query latency display.</a:t>
+              <a:t> Next.js 14/15 App Router interface styled using responsive vanilla Tailwind CSS.</a:t>
             </a:r>
           </a:p>
           <a:p>
             <a:pPr>
               <a:spcAft>
-                <a:spcPts val="1400"/>
+                <a:spcPts val="1000"/>
               </a:spcAft>
             </a:pPr>
             <a:r>
-              <a:rPr b="1" sz="1800">
+              <a:rPr b="1" sz="1600">
                 <a:solidFill>
                   <a:srgbClr val="F1F5F9"/>
                 </a:solidFill>
               </a:rPr>
-              <a:t>Server Tier:</a:t>
-            </a:r>
-            <a:r>
-              <a:rPr b="0" sz="1600">
+              <a:t>Backend (Server Tier):</a:t>
+            </a:r>
+            <a:r>
+              <a:rPr sz="1500">
                 <a:solidFill>
                   <a:srgbClr val="CBD5E1"/>
                 </a:solidFill>
               </a:rPr>
-              <a:t> Robust NestJS API Gateway managing file validation (via Zod schemas), request routing, embedding mapping, and storage transaction controls.</a:t>
+              <a:t> NestJS REST API Gateway handling security validation, pipeline routing, and embedder mapping.</a:t>
             </a:r>
           </a:p>
           <a:p>
             <a:pPr>
               <a:spcAft>
-                <a:spcPts val="1400"/>
+                <a:spcPts val="1000"/>
               </a:spcAft>
             </a:pPr>
             <a:r>
-              <a:rPr b="1" sz="1800">
+              <a:rPr b="1" sz="1600">
                 <a:solidFill>
                   <a:srgbClr val="F1F5F9"/>
                 </a:solidFill>
               </a:rPr>
-              <a:t>Storage Tier (PostgreSQL):</a:t>
-            </a:r>
-            <a:r>
-              <a:rPr b="0" sz="1600">
+              <a:t>Prisma ORM:</a:t>
+            </a:r>
+            <a:r>
+              <a:rPr sz="1500">
                 <a:solidFill>
                   <a:srgbClr val="CBD5E1"/>
                 </a:solidFill>
               </a:rPr>
-              <a:t> Neon Postgres relational database acting as the primary source of truth (message schemas, timestamps, user details).</a:t>
+              <a:t> Acts as the type-safe abstraction layer managing SQL queries, updates, and schema migrations.</a:t>
             </a:r>
           </a:p>
           <a:p>
             <a:pPr>
               <a:spcAft>
-                <a:spcPts val="1400"/>
+                <a:spcPts val="1000"/>
               </a:spcAft>
             </a:pPr>
             <a:r>
-              <a:rPr b="1" sz="1800">
+              <a:rPr b="1" sz="1600">
                 <a:solidFill>
                   <a:srgbClr val="F1F5F9"/>
                 </a:solidFill>
               </a:rPr>
-              <a:t>Storage Tier (Qdrant Cloud):</a:t>
-            </a:r>
-            <a:r>
-              <a:rPr b="0" sz="1600">
+              <a:t>Relational Database:</a:t>
+            </a:r>
+            <a:r>
+              <a:rPr sz="1500">
                 <a:solidFill>
                   <a:srgbClr val="CBD5E1"/>
                 </a:solidFill>
               </a:rPr>
-              <a:t> Managed high-performance Qdrant Vector database indexing the 384-dimensional dense semantic vectors for sub-10ms similarity lookup.</a:t>
+              <a:t> PostgreSQL (Neon Cloud) storing core metadata schemas, file batch logs, and message records.</a:t>
+            </a:r>
+          </a:p>
+          <a:p>
+            <a:pPr>
+              <a:spcAft>
+                <a:spcPts val="1000"/>
+              </a:spcAft>
+            </a:pPr>
+            <a:r>
+              <a:rPr b="1" sz="1600">
+                <a:solidFill>
+                  <a:srgbClr val="F1F5F9"/>
+                </a:solidFill>
+              </a:rPr>
+              <a:t>Vector Database:</a:t>
+            </a:r>
+            <a:r>
+              <a:rPr sz="1500">
+                <a:solidFill>
+                  <a:srgbClr val="CBD5E1"/>
+                </a:solidFill>
+              </a:rPr>
+              <a:t> Qdrant Cloud Cluster storing and indexing high-dimensional vector embeddings for near-instant search.</a:t>
             </a:r>
           </a:p>
         </p:txBody>
@@ -3546,8 +3646,8 @@
         </p:nvSpPr>
         <p:spPr>
           <a:xfrm>
-            <a:off x="685800" y="457200"/>
-            <a:ext cx="7772400" cy="914400"/>
+            <a:off x="685800" y="365760"/>
+            <a:ext cx="7772400" cy="1005840"/>
           </a:xfrm>
           <a:prstGeom prst="rect">
             <a:avLst/>
@@ -3561,14 +3661,26 @@
           <a:lstStyle/>
           <a:p>
             <a:pPr>
-              <a:defRPr b="1" sz="2800">
+              <a:defRPr b="1" sz="2600">
                 <a:solidFill>
                   <a:srgbClr val="38BDF8"/>
                 </a:solidFill>
               </a:defRPr>
             </a:pPr>
             <a:r>
-              <a:t>3. Ingestion &amp; Indexing Pipeline</a:t>
+              <a:t>3. Data Ingestion &amp; DB Write Flow</a:t>
+            </a:r>
+          </a:p>
+          <a:p>
+            <a:pPr>
+              <a:defRPr sz="1400" i="1">
+                <a:solidFill>
+                  <a:srgbClr val="94A3B8"/>
+                </a:solidFill>
+              </a:defRPr>
+            </a:pPr>
+            <a:r>
+              <a:t>Step-by-step sequence of uploading, validating, and persisting Telegram exports in both databases</a:t>
             </a:r>
           </a:p>
         </p:txBody>
@@ -3582,7 +3694,7 @@
         <p:spPr>
           <a:xfrm>
             <a:off x="685800" y="1371600"/>
-            <a:ext cx="7772400" cy="4572000"/>
+            <a:ext cx="7772400" cy="4754880"/>
           </a:xfrm>
           <a:prstGeom prst="rect">
             <a:avLst/>
@@ -3597,93 +3709,139 @@
           <a:p>
             <a:pPr>
               <a:spcAft>
-                <a:spcPts val="1400"/>
+                <a:spcPts val="1000"/>
               </a:spcAft>
             </a:pPr>
             <a:r>
-              <a:rPr b="1" sz="1800">
+              <a:rPr b="1" sz="1600">
                 <a:solidFill>
                   <a:srgbClr val="F1F5F9"/>
                 </a:solidFill>
               </a:rPr>
-              <a:t>Step 1 - File Upload:</a:t>
-            </a:r>
-            <a:r>
-              <a:rPr b="0" sz="1600">
+              <a:t>1. Upload Request:</a:t>
+            </a:r>
+            <a:r>
+              <a:rPr sz="1500">
                 <a:solidFill>
                   <a:srgbClr val="CBD5E1"/>
                 </a:solidFill>
               </a:rPr>
-              <a:t> The user drags a 'messages.json' file into the UI. The Next.js frontend POSTs it to the backend `/messages/upload` endpoint.</a:t>
+              <a:t> Frontend POSTs raw 'messages.json' multipart form data to NestJS API endpoint.</a:t>
             </a:r>
           </a:p>
           <a:p>
             <a:pPr>
               <a:spcAft>
-                <a:spcPts val="1400"/>
+                <a:spcPts val="1000"/>
               </a:spcAft>
             </a:pPr>
             <a:r>
-              <a:rPr b="1" sz="1800">
+              <a:rPr b="1" sz="1600">
                 <a:solidFill>
                   <a:srgbClr val="F1F5F9"/>
                 </a:solidFill>
               </a:rPr>
-              <a:t>Step 2 - Zod Validation:</a:t>
-            </a:r>
-            <a:r>
-              <a:rPr b="0" sz="1600">
+              <a:t>2. Schema Validation:</a:t>
+            </a:r>
+            <a:r>
+              <a:rPr sz="1500">
                 <a:solidFill>
                   <a:srgbClr val="CBD5E1"/>
                 </a:solidFill>
               </a:rPr>
-              <a:t> NestJS parses the JSON and validates it against a structured export schema to prevent malicious or malformed payloads.</a:t>
+              <a:t> NestJS validates input fields (e.g., handles, dates, reply ID structure) using Zod schema guards.</a:t>
             </a:r>
           </a:p>
           <a:p>
             <a:pPr>
               <a:spcAft>
-                <a:spcPts val="1400"/>
+                <a:spcPts val="1000"/>
               </a:spcAft>
             </a:pPr>
             <a:r>
-              <a:rPr b="1" sz="1800">
+              <a:rPr b="1" sz="1600">
                 <a:solidFill>
                   <a:srgbClr val="F1F5F9"/>
                 </a:solidFill>
               </a:rPr>
-              <a:t>Step 3 - Postgres Relational Sync:</a:t>
-            </a:r>
-            <a:r>
-              <a:rPr b="0" sz="1600">
+              <a:t>3. Relational Transaction:</a:t>
+            </a:r>
+            <a:r>
+              <a:rPr sz="1500">
                 <a:solidFill>
                   <a:srgbClr val="CBD5E1"/>
                 </a:solidFill>
               </a:rPr>
-              <a:t> Raw message text, sender handles, reply coordinates, and batch mappings are written to PostgreSQL.</a:t>
+              <a:t> A batch transaction generates a unique `ExportBatch` ID and stores all message records in PostgreSQL.</a:t>
             </a:r>
           </a:p>
           <a:p>
             <a:pPr>
               <a:spcAft>
-                <a:spcPts val="1400"/>
+                <a:spcPts val="1000"/>
               </a:spcAft>
             </a:pPr>
             <a:r>
-              <a:rPr b="1" sz="1800">
+              <a:rPr b="1" sz="1600">
                 <a:solidFill>
                   <a:srgbClr val="F1F5F9"/>
                 </a:solidFill>
               </a:rPr>
-              <a:t>Step 4 - Embedding &amp; Upsert:</a:t>
-            </a:r>
-            <a:r>
-              <a:rPr b="0" sz="1600">
+              <a:t>4. Vector Generation:</a:t>
+            </a:r>
+            <a:r>
+              <a:rPr sz="1500">
                 <a:solidFill>
                   <a:srgbClr val="CBD5E1"/>
                 </a:solidFill>
               </a:rPr>
-              <a:t> The local embedding service vectorizes text into a 384-d coordinate space, which is then upserted directly into Qdrant Cloud.</a:t>
+              <a:t> The backend triggers a local mapping function converting raw message strings into 384-dimensional vectors.</a:t>
+            </a:r>
+          </a:p>
+          <a:p>
+            <a:pPr>
+              <a:spcAft>
+                <a:spcPts val="1000"/>
+              </a:spcAft>
+            </a:pPr>
+            <a:r>
+              <a:rPr b="1" sz="1600">
+                <a:solidFill>
+                  <a:srgbClr val="F1F5F9"/>
+                </a:solidFill>
+              </a:rPr>
+              <a:t>5. Vector Ingest (Qdrant):</a:t>
+            </a:r>
+            <a:r>
+              <a:rPr sz="1500">
+                <a:solidFill>
+                  <a:srgbClr val="CBD5E1"/>
+                </a:solidFill>
+              </a:rPr>
+              <a:t> Generated embeddings, alongside reference IDs, are upserted into Qdrant Cloud Vector Database.</a:t>
+            </a:r>
+          </a:p>
+          <a:p>
+            <a:pPr lvl="1">
+              <a:spcAft>
+                <a:spcPts val="1000"/>
+              </a:spcAft>
+            </a:pPr>
+            <a:r>
+              <a:rPr b="1" sz="1400">
+                <a:solidFill>
+                  <a:srgbClr val="F1F5F9"/>
+                </a:solidFill>
+              </a:rPr>
+              <a:t>Integrity Lock:</a:t>
+            </a:r>
+            <a:r>
+              <a:rPr sz="1400">
+                <a:solidFill>
+                  <a:srgbClr val="CBD5E1"/>
+                </a:solidFill>
+              </a:rPr>
+              <a:t> Messages are tied across DBs: Qdrant points store their respective PostgreSQL database message IDs as reference payload.</a:t>
             </a:r>
           </a:p>
         </p:txBody>
@@ -3722,8 +3880,8 @@
         </p:nvSpPr>
         <p:spPr>
           <a:xfrm>
-            <a:off x="685800" y="457200"/>
-            <a:ext cx="7772400" cy="914400"/>
+            <a:off x="685800" y="365760"/>
+            <a:ext cx="7772400" cy="1005840"/>
           </a:xfrm>
           <a:prstGeom prst="rect">
             <a:avLst/>
@@ -3737,14 +3895,26 @@
           <a:lstStyle/>
           <a:p>
             <a:pPr>
-              <a:defRPr b="1" sz="2800">
+              <a:defRPr b="1" sz="2600">
                 <a:solidFill>
                   <a:srgbClr val="38BDF8"/>
                 </a:solidFill>
               </a:defRPr>
             </a:pPr>
             <a:r>
-              <a:t>4. Coordinate Mapping &amp; Technical Choices</a:t>
+              <a:t>4. Semantic Search Query Flow</a:t>
+            </a:r>
+          </a:p>
+          <a:p>
+            <a:pPr>
+              <a:defRPr sz="1400" i="1">
+                <a:solidFill>
+                  <a:srgbClr val="94A3B8"/>
+                </a:solidFill>
+              </a:defRPr>
+            </a:pPr>
+            <a:r>
+              <a:t>Step-by-step execution path from submitting a search term to rendering sorted matches</a:t>
             </a:r>
           </a:p>
         </p:txBody>
@@ -3758,7 +3928,7 @@
         <p:spPr>
           <a:xfrm>
             <a:off x="685800" y="1371600"/>
-            <a:ext cx="7772400" cy="4572000"/>
+            <a:ext cx="7772400" cy="4754880"/>
           </a:xfrm>
           <a:prstGeom prst="rect">
             <a:avLst/>
@@ -3773,93 +3943,561 @@
           <a:p>
             <a:pPr>
               <a:spcAft>
-                <a:spcPts val="1400"/>
+                <a:spcPts val="1000"/>
               </a:spcAft>
             </a:pPr>
             <a:r>
-              <a:rPr b="1" sz="1800">
+              <a:rPr b="1" sz="1600">
                 <a:solidFill>
                   <a:srgbClr val="F1F5F9"/>
                 </a:solidFill>
               </a:rPr>
-              <a:t>Semantic Clustering:</a:t>
-            </a:r>
-            <a:r>
-              <a:rPr b="0" sz="1600">
+              <a:t>1. Client POST request:</a:t>
+            </a:r>
+            <a:r>
+              <a:rPr sz="1500">
                 <a:solidFill>
                   <a:srgbClr val="CBD5E1"/>
                 </a:solidFill>
               </a:rPr>
-              <a:t> Maps and groups threat categories directly onto dedicated dimension spaces (e.g., Drugs on dimensions 10-40, Malware on 50-80).</a:t>
+              <a:t> Next.js submits search payload containing query text, score threshold, date range, and sender filter.</a:t>
             </a:r>
           </a:p>
           <a:p>
             <a:pPr>
               <a:spcAft>
-                <a:spcPts val="1400"/>
+                <a:spcPts val="1000"/>
               </a:spcAft>
             </a:pPr>
             <a:r>
-              <a:rPr b="1" sz="1800">
+              <a:rPr b="1" sz="1600">
                 <a:solidFill>
                   <a:srgbClr val="F1F5F9"/>
                 </a:solidFill>
               </a:rPr>
-              <a:t>Cosine Similarity:</a:t>
-            </a:r>
-            <a:r>
-              <a:rPr b="0" sz="1600">
+              <a:t>2. Query Mapping:</a:t>
+            </a:r>
+            <a:r>
+              <a:rPr sz="1500">
                 <a:solidFill>
                   <a:srgbClr val="CBD5E1"/>
                 </a:solidFill>
               </a:rPr>
-              <a:t> Uses vector distance logic inside Qdrant to compute semantic matches instantly, allowing real-time filtering.</a:t>
+              <a:t> NestJS converts search query text into a 384-dimensional vector using the local embedding coordinates model.</a:t>
             </a:r>
           </a:p>
           <a:p>
             <a:pPr>
               <a:spcAft>
-                <a:spcPts val="1400"/>
+                <a:spcPts val="1000"/>
               </a:spcAft>
             </a:pPr>
             <a:r>
-              <a:rPr b="1" sz="1800">
+              <a:rPr b="1" sz="1600">
                 <a:solidFill>
                   <a:srgbClr val="F1F5F9"/>
                 </a:solidFill>
               </a:rPr>
-              <a:t>Offline Embedding Model:</a:t>
-            </a:r>
-            <a:r>
-              <a:rPr b="0" sz="1600">
+              <a:t>3. Vector Match:</a:t>
+            </a:r>
+            <a:r>
+              <a:rPr sz="1500">
                 <a:solidFill>
                   <a:srgbClr val="CBD5E1"/>
                 </a:solidFill>
               </a:rPr>
-              <a:t> Avoids external LLM API costs and network latency by running the vectorizer model locally on the server (100% free &amp; secure).</a:t>
+              <a:t> Qdrant executes cosine distance calculations matching query against all database vectors.</a:t>
             </a:r>
           </a:p>
           <a:p>
             <a:pPr>
               <a:spcAft>
-                <a:spcPts val="1400"/>
+                <a:spcPts val="1000"/>
               </a:spcAft>
             </a:pPr>
             <a:r>
-              <a:rPr b="1" sz="1800">
+              <a:rPr b="1" sz="1600">
                 <a:solidFill>
                   <a:srgbClr val="F1F5F9"/>
                 </a:solidFill>
               </a:rPr>
-              <a:t>Enterprise Monorepo:</a:t>
-            </a:r>
-            <a:r>
-              <a:rPr b="0" sz="1600">
+              <a:t>4. Scores Retrieval:</a:t>
+            </a:r>
+            <a:r>
+              <a:rPr sz="1500">
                 <a:solidFill>
                   <a:srgbClr val="CBD5E1"/>
                 </a:solidFill>
               </a:rPr>
-              <a:t> Cohesive monorepo layout powered by TypeScript, Prisma ORM, Docker Compose, Jest testing, and OpenAPI Swagger documentation.</a:t>
+              <a:t> Qdrant returns top message point IDs matching the query vector alongside similarity coefficients.</a:t>
+            </a:r>
+          </a:p>
+          <a:p>
+            <a:pPr>
+              <a:spcAft>
+                <a:spcPts val="1000"/>
+              </a:spcAft>
+            </a:pPr>
+            <a:r>
+              <a:rPr b="1" sz="1600">
+                <a:solidFill>
+                  <a:srgbClr val="F1F5F9"/>
+                </a:solidFill>
+              </a:rPr>
+              <a:t>5. Metadata Assembly:</a:t>
+            </a:r>
+            <a:r>
+              <a:rPr sz="1500">
+                <a:solidFill>
+                  <a:srgbClr val="CBD5E1"/>
+                </a:solidFill>
+              </a:rPr>
+              <a:t> NestJS resolves point IDs against Postgres to get matching text, handles, dates, and thread replies.</a:t>
+            </a:r>
+          </a:p>
+          <a:p>
+            <a:pPr>
+              <a:spcAft>
+                <a:spcPts val="1000"/>
+              </a:spcAft>
+            </a:pPr>
+            <a:r>
+              <a:rPr b="1" sz="1600">
+                <a:solidFill>
+                  <a:srgbClr val="F1F5F9"/>
+                </a:solidFill>
+              </a:rPr>
+              <a:t>6. Sorting &amp; Hydration:</a:t>
+            </a:r>
+            <a:r>
+              <a:rPr sz="1500">
+                <a:solidFill>
+                  <a:srgbClr val="CBD5E1"/>
+                </a:solidFill>
+              </a:rPr>
+              <a:t> Results are filtered by criteria (dates, min score, handle) and returned to client as ranked arrays.</a:t>
+            </a:r>
+          </a:p>
+        </p:txBody>
+      </p:sp>
+    </p:spTree>
+  </p:cSld>
+  <p:clrMapOvr>
+    <a:masterClrMapping/>
+  </p:clrMapOvr>
+</p:sld>
+</file>
+
+<file path=ppt/slides/slide6.xml><?xml version="1.0" encoding="utf-8"?>
+<p:sld xmlns:a="http://schemas.openxmlformats.org/drawingml/2006/main" xmlns:p="http://schemas.openxmlformats.org/presentationml/2006/main" xmlns:r="http://schemas.openxmlformats.org/officeDocument/2006/relationships">
+  <p:cSld>
+    <p:bg>
+      <p:bgPr>
+        <a:solidFill>
+          <a:srgbClr val="0F172A"/>
+        </a:solidFill>
+        <a:effectLst/>
+      </p:bgPr>
+    </p:bg>
+    <p:spTree>
+      <p:nvGrpSpPr>
+        <p:cNvPr id="1" name=""/>
+        <p:cNvGrpSpPr/>
+        <p:nvPr/>
+      </p:nvGrpSpPr>
+      <p:grpSpPr/>
+      <p:sp>
+        <p:nvSpPr>
+          <p:cNvPr id="2" name="TextBox 1"/>
+          <p:cNvSpPr txBox="1"/>
+          <p:nvPr/>
+        </p:nvSpPr>
+        <p:spPr>
+          <a:xfrm>
+            <a:off x="685800" y="365760"/>
+            <a:ext cx="7772400" cy="1005840"/>
+          </a:xfrm>
+          <a:prstGeom prst="rect">
+            <a:avLst/>
+          </a:prstGeom>
+          <a:noFill/>
+        </p:spPr>
+        <p:txBody>
+          <a:bodyPr wrap="square">
+            <a:spAutoFit/>
+          </a:bodyPr>
+          <a:lstStyle/>
+          <a:p>
+            <a:pPr>
+              <a:defRPr b="1" sz="2600">
+                <a:solidFill>
+                  <a:srgbClr val="38BDF8"/>
+                </a:solidFill>
+              </a:defRPr>
+            </a:pPr>
+            <a:r>
+              <a:t>5. Under the Hood: Semantic Coordinate Mapping</a:t>
+            </a:r>
+          </a:p>
+          <a:p>
+            <a:pPr>
+              <a:defRPr sz="1400" i="1">
+                <a:solidFill>
+                  <a:srgbClr val="94A3B8"/>
+                </a:solidFill>
+              </a:defRPr>
+            </a:pPr>
+            <a:r>
+              <a:t>Lightweight mathematical modeling for zero-cost semantic search calculations</a:t>
+            </a:r>
+          </a:p>
+        </p:txBody>
+      </p:sp>
+      <p:sp>
+        <p:nvSpPr>
+          <p:cNvPr id="3" name="TextBox 2"/>
+          <p:cNvSpPr txBox="1"/>
+          <p:nvPr/>
+        </p:nvSpPr>
+        <p:spPr>
+          <a:xfrm>
+            <a:off x="685800" y="1371600"/>
+            <a:ext cx="7772400" cy="4754880"/>
+          </a:xfrm>
+          <a:prstGeom prst="rect">
+            <a:avLst/>
+          </a:prstGeom>
+          <a:noFill/>
+        </p:spPr>
+        <p:txBody>
+          <a:bodyPr wrap="square">
+            <a:spAutoFit/>
+          </a:bodyPr>
+          <a:lstStyle/>
+          <a:p>
+            <a:pPr>
+              <a:spcAft>
+                <a:spcPts val="1000"/>
+              </a:spcAft>
+            </a:pPr>
+            <a:r>
+              <a:rPr b="1" sz="1600">
+                <a:solidFill>
+                  <a:srgbClr val="F1F5F9"/>
+                </a:solidFill>
+              </a:rPr>
+              <a:t>Category Coordinate Bins:</a:t>
+            </a:r>
+            <a:r>
+              <a:rPr sz="1500">
+                <a:solidFill>
+                  <a:srgbClr val="CBD5E1"/>
+                </a:solidFill>
+              </a:rPr>
+              <a:t> Dimensions are segmented into cluster spaces (e.g. Dimensions 10-40 boost drugs, 50-80 boost malware).</a:t>
+            </a:r>
+          </a:p>
+          <a:p>
+            <a:pPr>
+              <a:spcAft>
+                <a:spcPts val="1000"/>
+              </a:spcAft>
+            </a:pPr>
+            <a:r>
+              <a:rPr b="1" sz="1600">
+                <a:solidFill>
+                  <a:srgbClr val="F1F5F9"/>
+                </a:solidFill>
+              </a:rPr>
+              <a:t>Cosine Similarity:</a:t>
+            </a:r>
+            <a:r>
+              <a:rPr sz="1500">
+                <a:solidFill>
+                  <a:srgbClr val="CBD5E1"/>
+                </a:solidFill>
+              </a:rPr>
+              <a:t> Measures the angular alignment between query and message vectors regardless of length, computed via:</a:t>
+            </a:r>
+          </a:p>
+          <a:p>
+            <a:pPr lvl="1">
+              <a:spcAft>
+                <a:spcPts val="1000"/>
+              </a:spcAft>
+            </a:pPr>
+            <a:r>
+              <a:rPr b="1" sz="1400">
+                <a:solidFill>
+                  <a:srgbClr val="F1F5F9"/>
+                </a:solidFill>
+              </a:rPr>
+              <a:t>Formula:</a:t>
+            </a:r>
+            <a:r>
+              <a:rPr sz="1400">
+                <a:solidFill>
+                  <a:srgbClr val="CBD5E1"/>
+                </a:solidFill>
+              </a:rPr>
+              <a:t> Similarity = (A . B) / (||A|| ||B||)</a:t>
+            </a:r>
+          </a:p>
+          <a:p>
+            <a:pPr>
+              <a:spcAft>
+                <a:spcPts val="1000"/>
+              </a:spcAft>
+            </a:pPr>
+            <a:r>
+              <a:rPr b="1" sz="1600">
+                <a:solidFill>
+                  <a:srgbClr val="F1F5F9"/>
+                </a:solidFill>
+              </a:rPr>
+              <a:t>Local Embedder Model:</a:t>
+            </a:r>
+            <a:r>
+              <a:rPr sz="1500">
+                <a:solidFill>
+                  <a:srgbClr val="CBD5E1"/>
+                </a:solidFill>
+              </a:rPr>
+              <a:t> Eliminates external network latency and third-party API costs by vectorizing locally on the NestJS Node process.</a:t>
+            </a:r>
+          </a:p>
+          <a:p>
+            <a:pPr>
+              <a:spcAft>
+                <a:spcPts val="1000"/>
+              </a:spcAft>
+            </a:pPr>
+            <a:r>
+              <a:rPr b="1" sz="1600">
+                <a:solidFill>
+                  <a:srgbClr val="F1F5F9"/>
+                </a:solidFill>
+              </a:rPr>
+              <a:t>Real-Time Response:</a:t>
+            </a:r>
+            <a:r>
+              <a:rPr sz="1500">
+                <a:solidFill>
+                  <a:srgbClr val="CBD5E1"/>
+                </a:solidFill>
+              </a:rPr>
+              <a:t> Delivers search matching capabilities in sub-10ms, allowing instantaneous updates as the user slides parameters.</a:t>
+            </a:r>
+          </a:p>
+        </p:txBody>
+      </p:sp>
+    </p:spTree>
+  </p:cSld>
+  <p:clrMapOvr>
+    <a:masterClrMapping/>
+  </p:clrMapOvr>
+</p:sld>
+</file>
+
+<file path=ppt/slides/slide7.xml><?xml version="1.0" encoding="utf-8"?>
+<p:sld xmlns:a="http://schemas.openxmlformats.org/drawingml/2006/main" xmlns:p="http://schemas.openxmlformats.org/presentationml/2006/main" xmlns:r="http://schemas.openxmlformats.org/officeDocument/2006/relationships">
+  <p:cSld>
+    <p:bg>
+      <p:bgPr>
+        <a:solidFill>
+          <a:srgbClr val="0F172A"/>
+        </a:solidFill>
+        <a:effectLst/>
+      </p:bgPr>
+    </p:bg>
+    <p:spTree>
+      <p:nvGrpSpPr>
+        <p:cNvPr id="1" name=""/>
+        <p:cNvGrpSpPr/>
+        <p:nvPr/>
+      </p:nvGrpSpPr>
+      <p:grpSpPr/>
+      <p:sp>
+        <p:nvSpPr>
+          <p:cNvPr id="2" name="TextBox 1"/>
+          <p:cNvSpPr txBox="1"/>
+          <p:nvPr/>
+        </p:nvSpPr>
+        <p:spPr>
+          <a:xfrm>
+            <a:off x="685800" y="365760"/>
+            <a:ext cx="7772400" cy="1005840"/>
+          </a:xfrm>
+          <a:prstGeom prst="rect">
+            <a:avLst/>
+          </a:prstGeom>
+          <a:noFill/>
+        </p:spPr>
+        <p:txBody>
+          <a:bodyPr wrap="square">
+            <a:spAutoFit/>
+          </a:bodyPr>
+          <a:lstStyle/>
+          <a:p>
+            <a:pPr>
+              <a:defRPr b="1" sz="2600">
+                <a:solidFill>
+                  <a:srgbClr val="38BDF8"/>
+                </a:solidFill>
+              </a:defRPr>
+            </a:pPr>
+            <a:r>
+              <a:t>6. Technical Rationale &amp; Choices</a:t>
+            </a:r>
+          </a:p>
+          <a:p>
+            <a:pPr>
+              <a:defRPr sz="1400" i="1">
+                <a:solidFill>
+                  <a:srgbClr val="94A3B8"/>
+                </a:solidFill>
+              </a:defRPr>
+            </a:pPr>
+            <a:r>
+              <a:t>Why these design decisions were selected for a production deployment</a:t>
+            </a:r>
+          </a:p>
+        </p:txBody>
+      </p:sp>
+      <p:sp>
+        <p:nvSpPr>
+          <p:cNvPr id="3" name="TextBox 2"/>
+          <p:cNvSpPr txBox="1"/>
+          <p:nvPr/>
+        </p:nvSpPr>
+        <p:spPr>
+          <a:xfrm>
+            <a:off x="685800" y="1371600"/>
+            <a:ext cx="7772400" cy="4754880"/>
+          </a:xfrm>
+          <a:prstGeom prst="rect">
+            <a:avLst/>
+          </a:prstGeom>
+          <a:noFill/>
+        </p:spPr>
+        <p:txBody>
+          <a:bodyPr wrap="square">
+            <a:spAutoFit/>
+          </a:bodyPr>
+          <a:lstStyle/>
+          <a:p>
+            <a:pPr>
+              <a:spcAft>
+                <a:spcPts val="1000"/>
+              </a:spcAft>
+            </a:pPr>
+            <a:r>
+              <a:rPr b="1" sz="1600">
+                <a:solidFill>
+                  <a:srgbClr val="F1F5F9"/>
+                </a:solidFill>
+              </a:rPr>
+              <a:t>Why Dual DB:</a:t>
+            </a:r>
+            <a:r>
+              <a:rPr sz="1500">
+                <a:solidFill>
+                  <a:srgbClr val="CBD5E1"/>
+                </a:solidFill>
+              </a:rPr>
+              <a:t> Relational DB guarantees structured ACID compliance and relations. Vector DB allows specialized geometry math.</a:t>
+            </a:r>
+          </a:p>
+          <a:p>
+            <a:pPr>
+              <a:spcAft>
+                <a:spcPts val="1000"/>
+              </a:spcAft>
+            </a:pPr>
+            <a:r>
+              <a:rPr b="1" sz="1600">
+                <a:solidFill>
+                  <a:srgbClr val="F1F5F9"/>
+                </a:solidFill>
+              </a:rPr>
+              <a:t>Why NestJS:</a:t>
+            </a:r>
+            <a:r>
+              <a:rPr sz="1500">
+                <a:solidFill>
+                  <a:srgbClr val="CBD5E1"/>
+                </a:solidFill>
+              </a:rPr>
+              <a:t> Module encapsulation, type safety, DI container structure, and CLI-based scaffolding maintain clean code architecture.</a:t>
+            </a:r>
+          </a:p>
+          <a:p>
+            <a:pPr>
+              <a:spcAft>
+                <a:spcPts val="1000"/>
+              </a:spcAft>
+            </a:pPr>
+            <a:r>
+              <a:rPr b="1" sz="1600">
+                <a:solidFill>
+                  <a:srgbClr val="F1F5F9"/>
+                </a:solidFill>
+              </a:rPr>
+              <a:t>Why Next.js App Router:</a:t>
+            </a:r>
+            <a:r>
+              <a:rPr sz="1500">
+                <a:solidFill>
+                  <a:srgbClr val="CBD5E1"/>
+                </a:solidFill>
+              </a:rPr>
+              <a:t> Dynamic Client Components for interactive UI controls combined with React hydration speed.</a:t>
+            </a:r>
+          </a:p>
+          <a:p>
+            <a:pPr>
+              <a:spcAft>
+                <a:spcPts val="1000"/>
+              </a:spcAft>
+            </a:pPr>
+            <a:r>
+              <a:rPr b="1" sz="1600">
+                <a:solidFill>
+                  <a:srgbClr val="F1F5F9"/>
+                </a:solidFill>
+              </a:rPr>
+              <a:t>Why Zod Schema:</a:t>
+            </a:r>
+            <a:r>
+              <a:rPr sz="1500">
+                <a:solidFill>
+                  <a:srgbClr val="CBD5E1"/>
+                </a:solidFill>
+              </a:rPr>
+              <a:t> Catches parsing bugs at the ingress point rather than letting corrupted JSON trigger errors inside databases.</a:t>
+            </a:r>
+          </a:p>
+          <a:p>
+            <a:pPr>
+              <a:spcAft>
+                <a:spcPts val="1000"/>
+              </a:spcAft>
+            </a:pPr>
+            <a:r>
+              <a:rPr b="1" sz="1600">
+                <a:solidFill>
+                  <a:srgbClr val="F1F5F9"/>
+                </a:solidFill>
+              </a:rPr>
+              <a:t>Monorepo Architecture:</a:t>
+            </a:r>
+            <a:r>
+              <a:rPr sz="1500">
+                <a:solidFill>
+                  <a:srgbClr val="CBD5E1"/>
+                </a:solidFill>
+              </a:rPr>
+              <a:t> Shared configs, unified builds, and simplified docker deployments manage frontend and backend in one place.</a:t>
             </a:r>
           </a:p>
         </p:txBody>

</xml_diff>